<commit_message>
Add the Word presentation, and carry the presenting attribution into both.
The presentation now exists in two forms from one set of content: the slide
deck, and a landscape Word document that renders each slide as a page with
its time allocation and speaker notes beneath it. Sixteen pages -- cover,
running order, seven presented slides, the closing page, five appendix pages
held for questions, and a delivery checklist.

Attribution is now explicit in both: presented by BYOND Asia, with AUREN
powered by HoloMe. HoloMe is named where it does the work -- the digital
human that delivers the interview -- rather than as a logo, so the mention
costs no presentation time and reads as architecture instead of branding.

This reverses the AUREN-facing firewall stance the deck shipped with
yesterday, on instruction.

Co-Authored-By: Claude Opus 5 <noreply@anthropic.com>
Claude-Session: https://claude.ai/code/session_01C2H69FBqTWQ1AbYhvyjYqM
</commit_message>
<xml_diff>
--- a/docs/AUREN-IOSCO-TechSprint-Demo-Day.pptx
+++ b/docs/AUREN-IOSCO-TechSprint-Demo-Day.pptx
@@ -515,7 +515,7 @@
           <a:p>
             <a:r>
               <a:rPr lang="en-US" dirty="0"/>
-              <a:t>Open cold, no self-introduction beyond a name. The first sentence is the thesis: 'Investor education tells people what to look for. Fraud does not arrive as information — it arrives as pressure.' TIMING: this slide is on screen for about 10 seconds.</a:t>
+              <a:t>Open cold — name, BYOND Asia, and straight in. No company history; you do not have the seconds. The first sentence is the thesis: 'Investor education tells people what to look for. Fraud does not arrive as information — it arrives as pressure.' TIMING: this slide is on screen for about 10 seconds.</a:t>
             </a:r>
             <a:endParaRPr lang="en-US" dirty="0"/>
           </a:p>
@@ -1666,7 +1666,7 @@
             <a:r>
               <a:rPr lang="en-US" dirty="0"/>
               <a:t>Say the two lines. Stop. Do not add a thank-you paragraph.
-TEAM NAME AND CONTACT: add them here only after checking them against the firewall rule (no companion-programme name, no client name, no parent brand on any AUREN-facing asset). Whatever entity you registered with IOSCO under is the name that belongs on this slide, and nothing else.</a:t>
+Add presenter names and a contact address here before the deck leaves the building.</a:t>
             </a:r>
             <a:endParaRPr lang="en-US" dirty="0"/>
           </a:p>
@@ -2091,6 +2091,45 @@
         </p:nvSpPr>
         <p:spPr>
           <a:xfrm>
+            <a:off x="658368" y="1517904"/>
+            <a:ext cx="7680960" cy="274320"/>
+          </a:xfrm>
+          <a:prstGeom prst="rect">
+            <a:avLst/>
+          </a:prstGeom>
+          <a:noFill/>
+          <a:ln/>
+        </p:spPr>
+        <p:txBody>
+          <a:bodyPr wrap="square" lIns="0" tIns="0" rIns="0" bIns="0" rtlCol="0" anchor="ctr"/>
+          <a:lstStyle/>
+          <a:p>
+            <a:pPr indent="0" marL="0">
+              <a:buNone/>
+            </a:pPr>
+            <a:r>
+              <a:rPr lang="en-US" sz="1300" b="1" spc="400" kern="0" dirty="0">
+                <a:solidFill>
+                  <a:srgbClr val="7C6BC4"/>
+                </a:solidFill>
+                <a:latin typeface="Calibri" pitchFamily="34" charset="0"/>
+                <a:ea typeface="Calibri" pitchFamily="34" charset="-122"/>
+                <a:cs typeface="Calibri" pitchFamily="34" charset="-120"/>
+              </a:rPr>
+              <a:t>BYOND ASIA</a:t>
+            </a:r>
+            <a:endParaRPr lang="en-US" sz="1300" dirty="0"/>
+          </a:p>
+        </p:txBody>
+      </p:sp>
+      <p:sp>
+        <p:nvSpPr>
+          <p:cNvPr id="5" name="Text 3"/>
+          <p:cNvSpPr txBox="1"/>
+          <p:nvPr/>
+        </p:nvSpPr>
+        <p:spPr>
+          <a:xfrm>
             <a:off x="658368" y="1874520"/>
             <a:ext cx="7680960" cy="1051560"/>
           </a:xfrm>
@@ -2124,7 +2163,7 @@
       </p:sp>
       <p:sp>
         <p:nvSpPr>
-          <p:cNvPr id="5" name="Text 3"/>
+          <p:cNvPr id="6" name="Text 4"/>
           <p:cNvSpPr txBox="1"/>
           <p:nvPr/>
         </p:nvSpPr>
@@ -2163,7 +2202,7 @@
       </p:sp>
       <p:sp>
         <p:nvSpPr>
-          <p:cNvPr id="6" name="Text 4"/>
+          <p:cNvPr id="7" name="Text 5"/>
           <p:cNvSpPr txBox="1"/>
           <p:nvPr/>
         </p:nvSpPr>
@@ -2205,7 +2244,7 @@
       </p:sp>
       <p:sp>
         <p:nvSpPr>
-          <p:cNvPr id="7" name="Shape 5"/>
+          <p:cNvPr id="8" name="Shape 6"/>
           <p:cNvSpPr/>
           <p:nvPr/>
         </p:nvSpPr>
@@ -2225,14 +2264,14 @@
       </p:sp>
       <p:sp>
         <p:nvSpPr>
-          <p:cNvPr id="8" name="Text 6"/>
+          <p:cNvPr id="9" name="Text 7"/>
           <p:cNvSpPr txBox="1"/>
           <p:nvPr/>
         </p:nvSpPr>
         <p:spPr>
           <a:xfrm>
             <a:off x="658368" y="5138928"/>
-            <a:ext cx="6400800" cy="274320"/>
+            <a:ext cx="7680960" cy="274320"/>
           </a:xfrm>
           <a:prstGeom prst="rect">
             <a:avLst/>
@@ -2256,7 +2295,7 @@
                 <a:ea typeface="Calibri" pitchFamily="34" charset="-122"/>
                 <a:cs typeface="Calibri" pitchFamily="34" charset="-120"/>
               </a:rPr>
-              <a:t>IOSCO TechSprint 2026  ·  Demo Day</a:t>
+              <a:t>Presented by BYOND Asia  ·  AUREN is powered by HoloMe</a:t>
             </a:r>
             <a:endParaRPr lang="en-US" sz="1300" dirty="0"/>
           </a:p>
@@ -2264,14 +2303,14 @@
       </p:sp>
       <p:sp>
         <p:nvSpPr>
-          <p:cNvPr id="9" name="Text 7"/>
+          <p:cNvPr id="10" name="Text 8"/>
           <p:cNvSpPr txBox="1"/>
           <p:nvPr/>
         </p:nvSpPr>
         <p:spPr>
           <a:xfrm>
             <a:off x="658368" y="5449824"/>
-            <a:ext cx="6400800" cy="274320"/>
+            <a:ext cx="7680960" cy="274320"/>
           </a:xfrm>
           <a:prstGeom prst="rect">
             <a:avLst/>
@@ -2295,7 +2334,7 @@
                 <a:ea typeface="Calibri" pitchFamily="34" charset="-122"/>
                 <a:cs typeface="Calibri" pitchFamily="34" charset="-120"/>
               </a:rPr>
-              <a:t>7-minute presentation  ·  3 minutes Q&amp;A</a:t>
+              <a:t>IOSCO TechSprint 2026  ·  Demo Day  ·  7 minutes + 3 minutes Q&amp;A</a:t>
             </a:r>
             <a:endParaRPr lang="en-US" sz="1200" dirty="0"/>
           </a:p>
@@ -9013,7 +9052,7 @@
                 <a:ea typeface="Calibri" pitchFamily="34" charset="-122"/>
                 <a:cs typeface="Calibri" pitchFamily="34" charset="-120"/>
               </a:rPr>
-              <a:t>A voice-led digital human runs a governed interview, then applies authentic sales pressure inside approved limits.</a:t>
+              <a:t>A HoloMe digital human runs a governed interview by voice, then applies authentic sales pressure inside approved limits.</a:t>
             </a:r>
             <a:endParaRPr lang="en-US" sz="1350" dirty="0"/>
           </a:p>
@@ -9965,7 +10004,7 @@
                 <a:ea typeface="Calibri" pitchFamily="34" charset="-122"/>
                 <a:cs typeface="Calibri" pitchFamily="34" charset="-120"/>
               </a:rPr>
-              <a:t>Digital human</a:t>
+              <a:t>HoloMe digital human</a:t>
             </a:r>
             <a:endParaRPr lang="en-US" sz="1450" dirty="0"/>
           </a:p>
@@ -12538,7 +12577,7 @@
                 <a:ea typeface="Calibri" pitchFamily="34" charset="-122"/>
                 <a:cs typeface="Calibri" pitchFamily="34" charset="-120"/>
               </a:rPr>
-              <a:t>Nothing reaches an investor until a mechanical publish gate passes. Ten tests, seven of them blocking, no waive path — not for a client, and not for us.</a:t>
+              <a:t>Nothing reaches an investor until a mechanical publish gate passes. Ten tests, seven of them blocking, no waive path — not for a client, and not for BYOND Asia.</a:t>
             </a:r>
             <a:endParaRPr lang="en-US" sz="1400" dirty="0"/>
           </a:p>
@@ -14869,7 +14908,7 @@
         <p:spPr>
           <a:xfrm>
             <a:off x="1024128" y="4078224"/>
-            <a:ext cx="5486400" cy="292608"/>
+            <a:ext cx="7863840" cy="292608"/>
           </a:xfrm>
           <a:prstGeom prst="rect">
             <a:avLst/>
@@ -14896,7 +14935,7 @@
                 <a:ea typeface="Calibri" pitchFamily="34" charset="-122"/>
                 <a:cs typeface="Calibri" pitchFamily="34" charset="-120"/>
               </a:rPr>
-              <a:t>AUREN  ·  IOSCO TechSprint 2026</a:t>
+              <a:t>BYOND Asia  ·  AUREN powered by HoloMe  ·  IOSCO TechSprint 2026</a:t>
             </a:r>
             <a:endParaRPr lang="en-US" sz="1300" dirty="0"/>
           </a:p>

</xml_diff>